<commit_message>
Set-up slides: download link for the stack test
Co-Authored-By: Claude Opus 5.5 <noreply@anthropic.com>
Claude-Session: https://claude.ai/code/session_01TbrdxHn7W6FVXXnpqzNytd
</commit_message>
<xml_diff>
--- a/slides/01a_setup-and-registration_WT26-27.pptx
+++ b/slides/01a_setup-and-registration_WT26-27.pptx
@@ -20533,8 +20533,8 @@
         </p:nvSpPr>
         <p:spPr>
           <a:xfrm>
-            <a:off x="457200" y="4663440"/>
-            <a:ext cx="8229600" cy="411480"/>
+            <a:off x="457200" y="4645152"/>
+            <a:ext cx="8229600" cy="475488"/>
           </a:xfrm>
           <a:prstGeom prst="rect">
             <a:avLst/>
@@ -20569,7 +20569,7 @@
       </p:sp>
       <p:pic>
         <p:nvPicPr>
-          <p:cNvPr id="30" name="Icon Test run" descr=""/>
+          <p:cNvPr id="30" name="Icon test download" descr=""/>
           <p:cNvPicPr>
             <a:picLocks noChangeAspect="1"/>
           </p:cNvPicPr>
@@ -20583,8 +20583,8 @@
         </p:blipFill>
         <p:spPr>
           <a:xfrm>
-            <a:off x="658368" y="4677156"/>
-            <a:ext cx="384048" cy="384048"/>
+            <a:off x="621792" y="4700016"/>
+            <a:ext cx="365760" cy="365760"/>
           </a:xfrm>
           <a:prstGeom prst="rect">
             <a:avLst/>
@@ -20599,8 +20599,8 @@
         </p:nvSpPr>
         <p:spPr>
           <a:xfrm>
-            <a:off x="1234440" y="4663440"/>
-            <a:ext cx="7269480" cy="411480"/>
+            <a:off x="1143000" y="4645152"/>
+            <a:ext cx="7452360" cy="475488"/>
           </a:xfrm>
           <a:prstGeom prst="rect">
             <a:avLst/>
@@ -20615,24 +20615,56 @@
           <a:p>
             <a:pPr algn="l">
               <a:spcAft>
-                <a:spcPts val="400"/>
+                <a:spcPts val="0"/>
               </a:spcAft>
             </a:pPr>
             <a:r>
-              <a:rPr sz="1300" b="1" lang="en-GB">
+              <a:rPr sz="1150" b="1" lang="en-GB">
                 <a:solidFill>
                   <a:schemeClr val="tx2"/>
                 </a:solidFill>
               </a:rPr>
+              <a:t>Download: </a:t>
+            </a:r>
+            <a:r>
+              <a:rPr sz="1150" b="0" lang="en-GB">
+                <a:solidFill>
+                  <a:schemeClr val="accent1"/>
+                </a:solidFill>
+                <a:hlinkClick r:id="rId4"/>
+              </a:rPr>
+              <a:t>test_stack.qmd on GitHub</a:t>
+            </a:r>
+            <a:r>
+              <a:rPr sz="1150" b="0" lang="en-GB">
+                <a:solidFill>
+                  <a:schemeClr val="tx1"/>
+                </a:solidFill>
+              </a:rPr>
+              <a:t> (button Download raw file) or on Canvas</a:t>
+            </a:r>
+          </a:p>
+          <a:p>
+            <a:pPr algn="l">
+              <a:spcAft>
+                <a:spcPts val="0"/>
+              </a:spcAft>
+            </a:pPr>
+            <a:r>
+              <a:rPr sz="1150" b="1" lang="en-GB">
+                <a:solidFill>
+                  <a:schemeClr val="tx2"/>
+                </a:solidFill>
+              </a:rPr>
               <a:t>Run it: </a:t>
             </a:r>
             <a:r>
-              <a:rPr sz="1300" b="0" lang="en-GB">
+              <a:rPr sz="1150" b="0" lang="en-GB">
                 <a:solidFill>
                   <a:schemeClr val="tx1"/>
                 </a:solidFill>
               </a:rPr>
-              <a:t>pick Python 3.14.8 (.venv), run cell 1 once, then Preview (Ctrl/Cmd + Shift + K).</a:t>
+              <a:t>pick Python 3.14.8 (.venv), run cell 1 once, then Preview (Ctrl/Cmd + Shift + K)</a:t>
             </a:r>
           </a:p>
         </p:txBody>

</xml_diff>